<commit_message>
fix(ppt): shrink fonts and tighten layout to prevent text overflow
- Reduce header height, footer height, and content margins
- Shrink title/body/KPI/card font sizes across all 3 PPTs
- Switch TOC to two-column layout to fit 6-8 items
- Tighten bullet line spacing and paragraph spacing
- Verify all text boxes fit within safe area

Co-Authored-By: Claude Fable 5 <noreply@anthropic.com>
</commit_message>
<xml_diff>
--- a/docs/ppt/Week1_公务员考试学习跟踪系统_阶段汇报.pptx
+++ b/docs/ppt/Week1_公务员考试学习跟踪系统_阶段汇报.pptx
@@ -3191,7 +3191,7 @@
         </p:nvSpPr>
         <p:spPr>
           <a:xfrm>
-            <a:off x="512064" y="1097280"/>
+            <a:off x="512064" y="1005840"/>
             <a:ext cx="11167567" cy="914400"/>
           </a:xfrm>
           <a:prstGeom prst="rect">
@@ -3209,7 +3209,7 @@
               <a:lnSpc>
                 <a:spcPct val="130000"/>
               </a:lnSpc>
-              <a:defRPr sz="4800" b="1">
+              <a:defRPr sz="4400" b="1">
                 <a:solidFill>
                   <a:srgbClr val="FFFFFF"/>
                 </a:solidFill>
@@ -3230,7 +3230,7 @@
         </p:nvSpPr>
         <p:spPr>
           <a:xfrm>
-            <a:off x="512064" y="2194560"/>
+            <a:off x="512064" y="2011680"/>
             <a:ext cx="11167567" cy="548640"/>
           </a:xfrm>
           <a:prstGeom prst="rect">
@@ -3248,7 +3248,7 @@
               <a:lnSpc>
                 <a:spcPct val="130000"/>
               </a:lnSpc>
-              <a:defRPr sz="2400" b="0">
+              <a:defRPr sz="2100" b="0">
                 <a:solidFill>
                   <a:srgbClr val="E8F4FC"/>
                 </a:solidFill>
@@ -3269,7 +3269,7 @@
         </p:nvSpPr>
         <p:spPr>
           <a:xfrm>
-            <a:off x="4267047" y="3200400"/>
+            <a:off x="4267047" y="2926080"/>
             <a:ext cx="3657600" cy="25400"/>
           </a:xfrm>
           <a:prstGeom prst="rect">
@@ -3312,7 +3312,7 @@
         </p:nvSpPr>
         <p:spPr>
           <a:xfrm>
-            <a:off x="6040983" y="3154680"/>
+            <a:off x="6040983" y="2880360"/>
             <a:ext cx="109728" cy="109728"/>
           </a:xfrm>
           <a:prstGeom prst="ellipse">
@@ -3355,7 +3355,7 @@
         </p:nvSpPr>
         <p:spPr>
           <a:xfrm>
-            <a:off x="512064" y="3840480"/>
+            <a:off x="512064" y="3474720"/>
             <a:ext cx="11167567" cy="1828800"/>
           </a:xfrm>
           <a:prstGeom prst="rect">
@@ -3371,9 +3371,9 @@
           <a:p>
             <a:pPr algn="ctr">
               <a:lnSpc>
-                <a:spcPct val="150000"/>
+                <a:spcPct val="125000"/>
               </a:lnSpc>
-              <a:defRPr sz="2000" b="0">
+              <a:defRPr sz="1700" b="0">
                 <a:solidFill>
                   <a:srgbClr val="666666"/>
                 </a:solidFill>
@@ -3406,7 +3406,7 @@
         </p:nvSpPr>
         <p:spPr>
           <a:xfrm>
-            <a:off x="512064" y="6400800"/>
+            <a:off x="512064" y="6528816"/>
             <a:ext cx="11167567" cy="12700"/>
           </a:xfrm>
           <a:prstGeom prst="rect">
@@ -3449,7 +3449,7 @@
         </p:nvSpPr>
         <p:spPr>
           <a:xfrm>
-            <a:off x="10948111" y="6492240"/>
+            <a:off x="10948111" y="6620256"/>
             <a:ext cx="731520" cy="274320"/>
           </a:xfrm>
           <a:prstGeom prst="rect">
@@ -3607,7 +3607,7 @@
               <a:lnSpc>
                 <a:spcPct val="130000"/>
               </a:lnSpc>
-              <a:defRPr sz="4800" b="1">
+              <a:defRPr sz="4400" b="1">
                 <a:solidFill>
                   <a:srgbClr val="FFFFFF"/>
                 </a:solidFill>
@@ -3628,7 +3628,7 @@
         </p:nvSpPr>
         <p:spPr>
           <a:xfrm>
-            <a:off x="512064" y="3200400"/>
+            <a:off x="512064" y="3108960"/>
             <a:ext cx="11167567" cy="548640"/>
           </a:xfrm>
           <a:prstGeom prst="rect">
@@ -3646,7 +3646,7 @@
               <a:lnSpc>
                 <a:spcPct val="130000"/>
               </a:lnSpc>
-              <a:defRPr sz="2400" b="0">
+              <a:defRPr sz="2100" b="0">
                 <a:solidFill>
                   <a:srgbClr val="E8F4FC"/>
                 </a:solidFill>
@@ -3667,7 +3667,7 @@
         </p:nvSpPr>
         <p:spPr>
           <a:xfrm>
-            <a:off x="512064" y="4114800"/>
+            <a:off x="512064" y="3840480"/>
             <a:ext cx="11167567" cy="1371600"/>
           </a:xfrm>
           <a:prstGeom prst="rect">
@@ -3683,9 +3683,9 @@
           <a:p>
             <a:pPr algn="ctr">
               <a:lnSpc>
-                <a:spcPct val="150000"/>
+                <a:spcPct val="125000"/>
               </a:lnSpc>
-              <a:defRPr sz="1600" b="0">
+              <a:defRPr sz="1400" b="0">
                 <a:solidFill>
                   <a:srgbClr val="CCCCCC"/>
                 </a:solidFill>
@@ -3710,7 +3710,7 @@
         </p:nvSpPr>
         <p:spPr>
           <a:xfrm>
-            <a:off x="512064" y="6400800"/>
+            <a:off x="512064" y="6528816"/>
             <a:ext cx="11167567" cy="12700"/>
           </a:xfrm>
           <a:prstGeom prst="rect">
@@ -3753,7 +3753,7 @@
         </p:nvSpPr>
         <p:spPr>
           <a:xfrm>
-            <a:off x="10948111" y="6492240"/>
+            <a:off x="10948111" y="6620256"/>
             <a:ext cx="731520" cy="274320"/>
           </a:xfrm>
           <a:prstGeom prst="rect">
@@ -3808,7 +3808,7 @@
         <p:spPr>
           <a:xfrm>
             <a:off x="0" y="0"/>
-            <a:ext cx="12191695" cy="886968"/>
+            <a:ext cx="12191695" cy="658368"/>
           </a:xfrm>
           <a:prstGeom prst="rect">
             <a:avLst/>
@@ -3851,7 +3851,7 @@
         <p:spPr>
           <a:xfrm>
             <a:off x="0" y="0"/>
-            <a:ext cx="54864" cy="886968"/>
+            <a:ext cx="54864" cy="658368"/>
           </a:xfrm>
           <a:prstGeom prst="rect">
             <a:avLst/>
@@ -3893,7 +3893,7 @@
         </p:nvSpPr>
         <p:spPr>
           <a:xfrm>
-            <a:off x="10308031" y="283464"/>
+            <a:off x="10308031" y="169164"/>
             <a:ext cx="1371600" cy="320040"/>
           </a:xfrm>
           <a:prstGeom prst="roundRect">
@@ -3952,7 +3952,7 @@
         </p:nvSpPr>
         <p:spPr>
           <a:xfrm>
-            <a:off x="603504" y="260604"/>
+            <a:off x="603504" y="146304"/>
             <a:ext cx="9613087" cy="457200"/>
           </a:xfrm>
           <a:prstGeom prst="rect">
@@ -3967,7 +3967,7 @@
           <a:lstStyle/>
           <a:p>
             <a:pPr>
-              <a:defRPr sz="2400" b="1">
+              <a:defRPr sz="2000" b="1">
                 <a:solidFill>
                   <a:srgbClr val="FFFFFF"/>
                 </a:solidFill>
@@ -3988,8 +3988,8 @@
         </p:nvSpPr>
         <p:spPr>
           <a:xfrm>
-            <a:off x="512064" y="1143000"/>
-            <a:ext cx="2286000" cy="548640"/>
+            <a:off x="512064" y="804672"/>
+            <a:ext cx="2286000" cy="457200"/>
           </a:xfrm>
           <a:prstGeom prst="rect">
             <a:avLst/>
@@ -4006,7 +4006,7 @@
               <a:lnSpc>
                 <a:spcPct val="130000"/>
               </a:lnSpc>
-              <a:defRPr sz="3200" b="1">
+              <a:defRPr sz="2600" b="1">
                 <a:solidFill>
                   <a:srgbClr val="003366"/>
                 </a:solidFill>
@@ -4027,8 +4027,8 @@
         </p:nvSpPr>
         <p:spPr>
           <a:xfrm>
-            <a:off x="512064" y="1965960"/>
-            <a:ext cx="11167567" cy="4105656"/>
+            <a:off x="512064" y="1399032"/>
+            <a:ext cx="5423763" cy="4928616"/>
           </a:xfrm>
           <a:prstGeom prst="rect">
             <a:avLst/>
@@ -4043,9 +4043,9 @@
           <a:p>
             <a:pPr>
               <a:spcAft>
-                <a:spcPts val="400"/>
+                <a:spcPts val="200"/>
               </a:spcAft>
-              <a:defRPr sz="2200" b="1">
+              <a:defRPr sz="1600" b="1">
                 <a:solidFill>
                   <a:srgbClr val="003366"/>
                 </a:solidFill>
@@ -4053,15 +4053,15 @@
               </a:defRPr>
             </a:pPr>
             <a:r>
-              <a:t>01    项目背景与目标</a:t>
+              <a:t>01  项目背景与目标</a:t>
             </a:r>
           </a:p>
           <a:p>
             <a:pPr>
               <a:spcAft>
-                <a:spcPts val="1600"/>
+                <a:spcPts val="1000"/>
               </a:spcAft>
-              <a:defRPr sz="1400">
+              <a:defRPr sz="1100">
                 <a:solidFill>
                   <a:srgbClr val="666666"/>
                 </a:solidFill>
@@ -4069,15 +4069,15 @@
               </a:defRPr>
             </a:pPr>
             <a:r>
-              <a:t>        面向在校大学生的公务员备考跟踪系统</a:t>
+              <a:t>     面向在校大学生的公务员备考跟踪系统</a:t>
             </a:r>
           </a:p>
           <a:p>
             <a:pPr>
               <a:spcAft>
-                <a:spcPts val="400"/>
+                <a:spcPts val="200"/>
               </a:spcAft>
-              <a:defRPr sz="2200" b="1">
+              <a:defRPr sz="1600" b="1">
                 <a:solidFill>
                   <a:srgbClr val="003366"/>
                 </a:solidFill>
@@ -4085,15 +4085,15 @@
               </a:defRPr>
             </a:pPr>
             <a:r>
-              <a:t>02    Week 1 概览</a:t>
+              <a:t>02  Week 1 概览</a:t>
             </a:r>
           </a:p>
           <a:p>
             <a:pPr>
               <a:spcAft>
-                <a:spcPts val="1600"/>
+                <a:spcPts val="1000"/>
               </a:spcAft>
-              <a:defRPr sz="1400">
+              <a:defRPr sz="1100">
                 <a:solidFill>
                   <a:srgbClr val="666666"/>
                 </a:solidFill>
@@ -4101,15 +4101,15 @@
               </a:defRPr>
             </a:pPr>
             <a:r>
-              <a:t>        搭建骨架、完成数据库与用户资源模块</a:t>
+              <a:t>     搭建骨架、完成数据库与用户资源模块</a:t>
             </a:r>
           </a:p>
           <a:p>
             <a:pPr>
               <a:spcAft>
-                <a:spcPts val="400"/>
+                <a:spcPts val="200"/>
               </a:spcAft>
-              <a:defRPr sz="2200" b="1">
+              <a:defRPr sz="1600" b="1">
                 <a:solidFill>
                   <a:srgbClr val="003366"/>
                 </a:solidFill>
@@ -4117,15 +4117,15 @@
               </a:defRPr>
             </a:pPr>
             <a:r>
-              <a:t>03    技术选型与架构</a:t>
+              <a:t>03  技术选型与架构</a:t>
             </a:r>
           </a:p>
           <a:p>
             <a:pPr>
               <a:spcAft>
-                <a:spcPts val="1600"/>
+                <a:spcPts val="1000"/>
               </a:spcAft>
-              <a:defRPr sz="1400">
+              <a:defRPr sz="1100">
                 <a:solidFill>
                   <a:srgbClr val="666666"/>
                 </a:solidFill>
@@ -4133,15 +4133,38 @@
               </a:defRPr>
             </a:pPr>
             <a:r>
-              <a:t>        Flask + MySQL + 原生 HTML/CSS/JS</a:t>
-            </a:r>
-          </a:p>
+              <a:t>     Flask + MySQL + 原生 HTML/CSS/JS</a:t>
+            </a:r>
+          </a:p>
+        </p:txBody>
+      </p:sp>
+      <p:sp>
+        <p:nvSpPr>
+          <p:cNvPr id="8" name="TextBox 7"/>
+          <p:cNvSpPr txBox="1"/>
+          <p:nvPr/>
+        </p:nvSpPr>
+        <p:spPr>
+          <a:xfrm>
+            <a:off x="6255867" y="1399032"/>
+            <a:ext cx="5423763" cy="4928616"/>
+          </a:xfrm>
+          <a:prstGeom prst="rect">
+            <a:avLst/>
+          </a:prstGeom>
+          <a:noFill/>
+        </p:spPr>
+        <p:txBody>
+          <a:bodyPr wrap="square">
+            <a:spAutoFit/>
+          </a:bodyPr>
+          <a:lstStyle/>
           <a:p>
             <a:pPr>
               <a:spcAft>
-                <a:spcPts val="400"/>
+                <a:spcPts val="200"/>
               </a:spcAft>
-              <a:defRPr sz="2200" b="1">
+              <a:defRPr sz="1600" b="1">
                 <a:solidFill>
                   <a:srgbClr val="003366"/>
                 </a:solidFill>
@@ -4149,15 +4172,15 @@
               </a:defRPr>
             </a:pPr>
             <a:r>
-              <a:t>04    数据库设计</a:t>
+              <a:t>04  数据库设计</a:t>
             </a:r>
           </a:p>
           <a:p>
             <a:pPr>
               <a:spcAft>
-                <a:spcPts val="1600"/>
+                <a:spcPts val="1000"/>
               </a:spcAft>
-              <a:defRPr sz="1400">
+              <a:defRPr sz="1100">
                 <a:solidFill>
                   <a:srgbClr val="666666"/>
                 </a:solidFill>
@@ -4165,15 +4188,15 @@
               </a:defRPr>
             </a:pPr>
             <a:r>
-              <a:t>        12 张核心表 + 11 个索引</a:t>
+              <a:t>     12 张核心表 + 11 个索引</a:t>
             </a:r>
           </a:p>
           <a:p>
             <a:pPr>
               <a:spcAft>
-                <a:spcPts val="400"/>
+                <a:spcPts val="200"/>
               </a:spcAft>
-              <a:defRPr sz="2200" b="1">
+              <a:defRPr sz="1600" b="1">
                 <a:solidFill>
                   <a:srgbClr val="003366"/>
                 </a:solidFill>
@@ -4181,15 +4204,15 @@
               </a:defRPr>
             </a:pPr>
             <a:r>
-              <a:t>05    用户与资源模块</a:t>
+              <a:t>05  用户与资源模块</a:t>
             </a:r>
           </a:p>
           <a:p>
             <a:pPr>
               <a:spcAft>
-                <a:spcPts val="1600"/>
+                <a:spcPts val="1000"/>
               </a:spcAft>
-              <a:defRPr sz="1400">
+              <a:defRPr sz="1100">
                 <a:solidFill>
                   <a:srgbClr val="666666"/>
                 </a:solidFill>
@@ -4197,15 +4220,15 @@
               </a:defRPr>
             </a:pPr>
             <a:r>
-              <a:t>        Session 认证 + 23 条备考资源</a:t>
+              <a:t>     Session 认证 + 23 条备考资源</a:t>
             </a:r>
           </a:p>
           <a:p>
             <a:pPr>
               <a:spcAft>
-                <a:spcPts val="400"/>
+                <a:spcPts val="200"/>
               </a:spcAft>
-              <a:defRPr sz="2200" b="1">
+              <a:defRPr sz="1600" b="1">
                 <a:solidFill>
                   <a:srgbClr val="003366"/>
                 </a:solidFill>
@@ -4213,15 +4236,15 @@
               </a:defRPr>
             </a:pPr>
             <a:r>
-              <a:t>06    后续计划</a:t>
+              <a:t>06  后续计划</a:t>
             </a:r>
           </a:p>
           <a:p>
             <a:pPr>
               <a:spcAft>
-                <a:spcPts val="1600"/>
+                <a:spcPts val="1000"/>
               </a:spcAft>
-              <a:defRPr sz="1400">
+              <a:defRPr sz="1100">
                 <a:solidFill>
                   <a:srgbClr val="666666"/>
                 </a:solidFill>
@@ -4229,20 +4252,20 @@
               </a:defRPr>
             </a:pPr>
             <a:r>
-              <a:t>        Week 2 将完成题库、计划、统计、推荐、答疑</a:t>
-            </a:r>
-          </a:p>
-        </p:txBody>
-      </p:sp>
-      <p:sp>
-        <p:nvSpPr>
-          <p:cNvPr id="8" name="Rectangle 7"/>
+              <a:t>     Week 2 将完成题库、计划、统计、推荐、答疑</a:t>
+            </a:r>
+          </a:p>
+        </p:txBody>
+      </p:sp>
+      <p:sp>
+        <p:nvSpPr>
+          <p:cNvPr id="9" name="Rectangle 8"/>
           <p:cNvSpPr/>
           <p:nvPr/>
         </p:nvSpPr>
         <p:spPr>
           <a:xfrm>
-            <a:off x="512064" y="6400800"/>
+            <a:off x="512064" y="6528816"/>
             <a:ext cx="11167567" cy="12700"/>
           </a:xfrm>
           <a:prstGeom prst="rect">
@@ -4279,13 +4302,13 @@
       </p:sp>
       <p:sp>
         <p:nvSpPr>
-          <p:cNvPr id="9" name="TextBox 8"/>
+          <p:cNvPr id="10" name="TextBox 9"/>
           <p:cNvSpPr txBox="1"/>
           <p:nvPr/>
         </p:nvSpPr>
         <p:spPr>
           <a:xfrm>
-            <a:off x="10948111" y="6492240"/>
+            <a:off x="10948111" y="6620256"/>
             <a:ext cx="731520" cy="274320"/>
           </a:xfrm>
           <a:prstGeom prst="rect">
@@ -4340,7 +4363,7 @@
         <p:spPr>
           <a:xfrm>
             <a:off x="0" y="0"/>
-            <a:ext cx="12191695" cy="886968"/>
+            <a:ext cx="12191695" cy="658368"/>
           </a:xfrm>
           <a:prstGeom prst="rect">
             <a:avLst/>
@@ -4383,7 +4406,7 @@
         <p:spPr>
           <a:xfrm>
             <a:off x="0" y="0"/>
-            <a:ext cx="54864" cy="886968"/>
+            <a:ext cx="54864" cy="658368"/>
           </a:xfrm>
           <a:prstGeom prst="rect">
             <a:avLst/>
@@ -4425,7 +4448,7 @@
         </p:nvSpPr>
         <p:spPr>
           <a:xfrm>
-            <a:off x="10308031" y="283464"/>
+            <a:off x="10308031" y="169164"/>
             <a:ext cx="1371600" cy="320040"/>
           </a:xfrm>
           <a:prstGeom prst="roundRect">
@@ -4484,7 +4507,7 @@
         </p:nvSpPr>
         <p:spPr>
           <a:xfrm>
-            <a:off x="603504" y="260604"/>
+            <a:off x="603504" y="146304"/>
             <a:ext cx="9613087" cy="457200"/>
           </a:xfrm>
           <a:prstGeom prst="rect">
@@ -4499,7 +4522,7 @@
           <a:lstStyle/>
           <a:p>
             <a:pPr>
-              <a:defRPr sz="2400" b="1">
+              <a:defRPr sz="2000" b="1">
                 <a:solidFill>
                   <a:srgbClr val="FFFFFF"/>
                 </a:solidFill>
@@ -4520,8 +4543,8 @@
         </p:nvSpPr>
         <p:spPr>
           <a:xfrm>
-            <a:off x="512064" y="1325880"/>
-            <a:ext cx="11167567" cy="4837176"/>
+            <a:off x="512064" y="941832"/>
+            <a:ext cx="11167567" cy="5431536"/>
           </a:xfrm>
           <a:prstGeom prst="rect">
             <a:avLst/>
@@ -4536,12 +4559,12 @@
           <a:p>
             <a:pPr>
               <a:lnSpc>
-                <a:spcPct val="130000"/>
+                <a:spcPct val="110000"/>
               </a:lnSpc>
               <a:spcAft>
-                <a:spcPts val="1000"/>
+                <a:spcPts val="400"/>
               </a:spcAft>
-              <a:defRPr sz="2000">
+              <a:defRPr sz="1700">
                 <a:solidFill>
                   <a:srgbClr val="333333"/>
                 </a:solidFill>
@@ -4555,12 +4578,12 @@
           <a:p>
             <a:pPr>
               <a:lnSpc>
-                <a:spcPct val="130000"/>
+                <a:spcPct val="110000"/>
               </a:lnSpc>
               <a:spcAft>
-                <a:spcPts val="1000"/>
+                <a:spcPts val="400"/>
               </a:spcAft>
-              <a:defRPr sz="2000">
+              <a:defRPr sz="1700">
                 <a:solidFill>
                   <a:srgbClr val="333333"/>
                 </a:solidFill>
@@ -4574,12 +4597,12 @@
           <a:p>
             <a:pPr>
               <a:lnSpc>
-                <a:spcPct val="130000"/>
+                <a:spcPct val="110000"/>
               </a:lnSpc>
               <a:spcAft>
-                <a:spcPts val="1000"/>
+                <a:spcPts val="400"/>
               </a:spcAft>
-              <a:defRPr sz="2000">
+              <a:defRPr sz="1700">
                 <a:solidFill>
                   <a:srgbClr val="333333"/>
                 </a:solidFill>
@@ -4593,12 +4616,12 @@
           <a:p>
             <a:pPr>
               <a:lnSpc>
-                <a:spcPct val="130000"/>
+                <a:spcPct val="110000"/>
               </a:lnSpc>
               <a:spcAft>
-                <a:spcPts val="1000"/>
+                <a:spcPts val="400"/>
               </a:spcAft>
-              <a:defRPr sz="2000">
+              <a:defRPr sz="1700">
                 <a:solidFill>
                   <a:srgbClr val="333333"/>
                 </a:solidFill>
@@ -4612,12 +4635,12 @@
           <a:p>
             <a:pPr>
               <a:lnSpc>
-                <a:spcPct val="130000"/>
+                <a:spcPct val="110000"/>
               </a:lnSpc>
               <a:spcAft>
-                <a:spcPts val="1000"/>
+                <a:spcPts val="400"/>
               </a:spcAft>
-              <a:defRPr sz="2000">
+              <a:defRPr sz="1700">
                 <a:solidFill>
                   <a:srgbClr val="333333"/>
                 </a:solidFill>
@@ -4638,7 +4661,7 @@
         </p:nvSpPr>
         <p:spPr>
           <a:xfrm>
-            <a:off x="512064" y="6400800"/>
+            <a:off x="512064" y="6528816"/>
             <a:ext cx="11167567" cy="12700"/>
           </a:xfrm>
           <a:prstGeom prst="rect">
@@ -4681,7 +4704,7 @@
         </p:nvSpPr>
         <p:spPr>
           <a:xfrm>
-            <a:off x="10948111" y="6492240"/>
+            <a:off x="10948111" y="6620256"/>
             <a:ext cx="731520" cy="274320"/>
           </a:xfrm>
           <a:prstGeom prst="rect">
@@ -4736,7 +4759,7 @@
         <p:spPr>
           <a:xfrm>
             <a:off x="0" y="0"/>
-            <a:ext cx="12191695" cy="886968"/>
+            <a:ext cx="12191695" cy="658368"/>
           </a:xfrm>
           <a:prstGeom prst="rect">
             <a:avLst/>
@@ -4779,7 +4802,7 @@
         <p:spPr>
           <a:xfrm>
             <a:off x="0" y="0"/>
-            <a:ext cx="54864" cy="886968"/>
+            <a:ext cx="54864" cy="658368"/>
           </a:xfrm>
           <a:prstGeom prst="rect">
             <a:avLst/>
@@ -4821,7 +4844,7 @@
         </p:nvSpPr>
         <p:spPr>
           <a:xfrm>
-            <a:off x="10308031" y="283464"/>
+            <a:off x="10308031" y="169164"/>
             <a:ext cx="1371600" cy="320040"/>
           </a:xfrm>
           <a:prstGeom prst="roundRect">
@@ -4880,7 +4903,7 @@
         </p:nvSpPr>
         <p:spPr>
           <a:xfrm>
-            <a:off x="603504" y="260604"/>
+            <a:off x="603504" y="146304"/>
             <a:ext cx="9613087" cy="457200"/>
           </a:xfrm>
           <a:prstGeom prst="rect">
@@ -4895,7 +4918,7 @@
           <a:lstStyle/>
           <a:p>
             <a:pPr>
-              <a:defRPr sz="2400" b="1">
+              <a:defRPr sz="2000" b="1">
                 <a:solidFill>
                   <a:srgbClr val="FFFFFF"/>
                 </a:solidFill>
@@ -4916,8 +4939,8 @@
         </p:nvSpPr>
         <p:spPr>
           <a:xfrm>
-            <a:off x="512064" y="1508760"/>
-            <a:ext cx="2620441" cy="1463040"/>
+            <a:off x="512064" y="1033272"/>
+            <a:ext cx="2654731" cy="1143000"/>
           </a:xfrm>
           <a:prstGeom prst="roundRect">
             <a:avLst/>
@@ -4949,38 +4972,38 @@
           <a:p>
             <a:pPr algn="ctr">
               <a:spcAft>
+                <a:spcPts val="200"/>
+              </a:spcAft>
+              <a:defRPr sz="3000" b="1">
+                <a:solidFill>
+                  <a:srgbClr val="0066CC"/>
+                </a:solidFill>
+                <a:latin typeface="Microsoft YaHei"/>
+              </a:defRPr>
+            </a:pPr>
+            <a:r>
+              <a:t>11</a:t>
+            </a:r>
+          </a:p>
+          <a:p>
+            <a:pPr algn="ctr">
+              <a:spcAft>
                 <a:spcPts val="400"/>
               </a:spcAft>
-              <a:defRPr sz="3600" b="1">
-                <a:solidFill>
-                  <a:srgbClr val="0066CC"/>
-                </a:solidFill>
-                <a:latin typeface="Microsoft YaHei"/>
-              </a:defRPr>
-            </a:pPr>
-            <a:r>
-              <a:t>11</a:t>
+              <a:defRPr sz="1100">
+                <a:solidFill>
+                  <a:srgbClr val="666666"/>
+                </a:solidFill>
+                <a:latin typeface="Microsoft YaHei"/>
+              </a:defRPr>
+            </a:pPr>
+            <a:r>
+              <a:t>次</a:t>
             </a:r>
           </a:p>
           <a:p>
             <a:pPr algn="ctr">
-              <a:spcAft>
-                <a:spcPts val="800"/>
-              </a:spcAft>
-              <a:defRPr sz="1400">
-                <a:solidFill>
-                  <a:srgbClr val="666666"/>
-                </a:solidFill>
-                <a:latin typeface="Microsoft YaHei"/>
-              </a:defRPr>
-            </a:pPr>
-            <a:r>
-              <a:t>次</a:t>
-            </a:r>
-          </a:p>
-          <a:p>
-            <a:pPr algn="ctr">
-              <a:defRPr sz="1400">
+              <a:defRPr sz="1100">
                 <a:solidFill>
                   <a:srgbClr val="333333"/>
                 </a:solidFill>
@@ -5001,8 +5024,8 @@
         </p:nvSpPr>
         <p:spPr>
           <a:xfrm>
-            <a:off x="3361105" y="1508760"/>
-            <a:ext cx="2620441" cy="1463040"/>
+            <a:off x="3349675" y="1033272"/>
+            <a:ext cx="2654731" cy="1143000"/>
           </a:xfrm>
           <a:prstGeom prst="roundRect">
             <a:avLst/>
@@ -5034,38 +5057,38 @@
           <a:p>
             <a:pPr algn="ctr">
               <a:spcAft>
+                <a:spcPts val="200"/>
+              </a:spcAft>
+              <a:defRPr sz="3000" b="1">
+                <a:solidFill>
+                  <a:srgbClr val="0066CC"/>
+                </a:solidFill>
+                <a:latin typeface="Microsoft YaHei"/>
+              </a:defRPr>
+            </a:pPr>
+            <a:r>
+              <a:t>32</a:t>
+            </a:r>
+          </a:p>
+          <a:p>
+            <a:pPr algn="ctr">
+              <a:spcAft>
                 <a:spcPts val="400"/>
               </a:spcAft>
-              <a:defRPr sz="3600" b="1">
-                <a:solidFill>
-                  <a:srgbClr val="0066CC"/>
-                </a:solidFill>
-                <a:latin typeface="Microsoft YaHei"/>
-              </a:defRPr>
-            </a:pPr>
-            <a:r>
-              <a:t>32</a:t>
+              <a:defRPr sz="1100">
+                <a:solidFill>
+                  <a:srgbClr val="666666"/>
+                </a:solidFill>
+                <a:latin typeface="Microsoft YaHei"/>
+              </a:defRPr>
+            </a:pPr>
+            <a:r>
+              <a:t>个</a:t>
             </a:r>
           </a:p>
           <a:p>
             <a:pPr algn="ctr">
-              <a:spcAft>
-                <a:spcPts val="800"/>
-              </a:spcAft>
-              <a:defRPr sz="1400">
-                <a:solidFill>
-                  <a:srgbClr val="666666"/>
-                </a:solidFill>
-                <a:latin typeface="Microsoft YaHei"/>
-              </a:defRPr>
-            </a:pPr>
-            <a:r>
-              <a:t>个</a:t>
-            </a:r>
-          </a:p>
-          <a:p>
-            <a:pPr algn="ctr">
-              <a:defRPr sz="1400">
+              <a:defRPr sz="1100">
                 <a:solidFill>
                   <a:srgbClr val="333333"/>
                 </a:solidFill>
@@ -5086,8 +5109,8 @@
         </p:nvSpPr>
         <p:spPr>
           <a:xfrm>
-            <a:off x="6210147" y="1508760"/>
-            <a:ext cx="2620441" cy="1463040"/>
+            <a:off x="6187287" y="1033272"/>
+            <a:ext cx="2654731" cy="1143000"/>
           </a:xfrm>
           <a:prstGeom prst="roundRect">
             <a:avLst/>
@@ -5119,38 +5142,38 @@
           <a:p>
             <a:pPr algn="ctr">
               <a:spcAft>
+                <a:spcPts val="200"/>
+              </a:spcAft>
+              <a:defRPr sz="3000" b="1">
+                <a:solidFill>
+                  <a:srgbClr val="0066CC"/>
+                </a:solidFill>
+                <a:latin typeface="Microsoft YaHei"/>
+              </a:defRPr>
+            </a:pPr>
+            <a:r>
+              <a:t>12</a:t>
+            </a:r>
+          </a:p>
+          <a:p>
+            <a:pPr algn="ctr">
+              <a:spcAft>
                 <a:spcPts val="400"/>
               </a:spcAft>
-              <a:defRPr sz="3600" b="1">
-                <a:solidFill>
-                  <a:srgbClr val="0066CC"/>
-                </a:solidFill>
-                <a:latin typeface="Microsoft YaHei"/>
-              </a:defRPr>
-            </a:pPr>
-            <a:r>
-              <a:t>12</a:t>
+              <a:defRPr sz="1100">
+                <a:solidFill>
+                  <a:srgbClr val="666666"/>
+                </a:solidFill>
+                <a:latin typeface="Microsoft YaHei"/>
+              </a:defRPr>
+            </a:pPr>
+            <a:r>
+              <a:t>张</a:t>
             </a:r>
           </a:p>
           <a:p>
             <a:pPr algn="ctr">
-              <a:spcAft>
-                <a:spcPts val="800"/>
-              </a:spcAft>
-              <a:defRPr sz="1400">
-                <a:solidFill>
-                  <a:srgbClr val="666666"/>
-                </a:solidFill>
-                <a:latin typeface="Microsoft YaHei"/>
-              </a:defRPr>
-            </a:pPr>
-            <a:r>
-              <a:t>张</a:t>
-            </a:r>
-          </a:p>
-          <a:p>
-            <a:pPr algn="ctr">
-              <a:defRPr sz="1400">
+              <a:defRPr sz="1100">
                 <a:solidFill>
                   <a:srgbClr val="333333"/>
                 </a:solidFill>
@@ -5171,8 +5194,8 @@
         </p:nvSpPr>
         <p:spPr>
           <a:xfrm>
-            <a:off x="9059189" y="1508760"/>
-            <a:ext cx="2620441" cy="1463040"/>
+            <a:off x="9024899" y="1033272"/>
+            <a:ext cx="2654731" cy="1143000"/>
           </a:xfrm>
           <a:prstGeom prst="roundRect">
             <a:avLst/>
@@ -5204,38 +5227,38 @@
           <a:p>
             <a:pPr algn="ctr">
               <a:spcAft>
+                <a:spcPts val="200"/>
+              </a:spcAft>
+              <a:defRPr sz="3000" b="1">
+                <a:solidFill>
+                  <a:srgbClr val="0066CC"/>
+                </a:solidFill>
+                <a:latin typeface="Microsoft YaHei"/>
+              </a:defRPr>
+            </a:pPr>
+            <a:r>
+              <a:t>23</a:t>
+            </a:r>
+          </a:p>
+          <a:p>
+            <a:pPr algn="ctr">
+              <a:spcAft>
                 <a:spcPts val="400"/>
               </a:spcAft>
-              <a:defRPr sz="3600" b="1">
-                <a:solidFill>
-                  <a:srgbClr val="0066CC"/>
-                </a:solidFill>
-                <a:latin typeface="Microsoft YaHei"/>
-              </a:defRPr>
-            </a:pPr>
-            <a:r>
-              <a:t>23</a:t>
+              <a:defRPr sz="1100">
+                <a:solidFill>
+                  <a:srgbClr val="666666"/>
+                </a:solidFill>
+                <a:latin typeface="Microsoft YaHei"/>
+              </a:defRPr>
+            </a:pPr>
+            <a:r>
+              <a:t>条</a:t>
             </a:r>
           </a:p>
           <a:p>
             <a:pPr algn="ctr">
-              <a:spcAft>
-                <a:spcPts val="800"/>
-              </a:spcAft>
-              <a:defRPr sz="1400">
-                <a:solidFill>
-                  <a:srgbClr val="666666"/>
-                </a:solidFill>
-                <a:latin typeface="Microsoft YaHei"/>
-              </a:defRPr>
-            </a:pPr>
-            <a:r>
-              <a:t>条</a:t>
-            </a:r>
-          </a:p>
-          <a:p>
-            <a:pPr algn="ctr">
-              <a:defRPr sz="1400">
+              <a:defRPr sz="1100">
                 <a:solidFill>
                   <a:srgbClr val="333333"/>
                 </a:solidFill>
@@ -5256,8 +5279,8 @@
         </p:nvSpPr>
         <p:spPr>
           <a:xfrm>
-            <a:off x="512064" y="3154680"/>
-            <a:ext cx="11167567" cy="3008376"/>
+            <a:off x="512064" y="2496312"/>
+            <a:ext cx="11167567" cy="3877056"/>
           </a:xfrm>
           <a:prstGeom prst="rect">
             <a:avLst/>
@@ -5272,12 +5295,12 @@
           <a:p>
             <a:pPr>
               <a:lnSpc>
-                <a:spcPct val="130000"/>
+                <a:spcPct val="110000"/>
               </a:lnSpc>
               <a:spcAft>
-                <a:spcPts val="1000"/>
+                <a:spcPts val="400"/>
               </a:spcAft>
-              <a:defRPr sz="1800">
+              <a:defRPr sz="1700">
                 <a:solidFill>
                   <a:srgbClr val="333333"/>
                 </a:solidFill>
@@ -5291,12 +5314,12 @@
           <a:p>
             <a:pPr>
               <a:lnSpc>
-                <a:spcPct val="130000"/>
+                <a:spcPct val="110000"/>
               </a:lnSpc>
               <a:spcAft>
-                <a:spcPts val="1000"/>
+                <a:spcPts val="400"/>
               </a:spcAft>
-              <a:defRPr sz="1800">
+              <a:defRPr sz="1700">
                 <a:solidFill>
                   <a:srgbClr val="333333"/>
                 </a:solidFill>
@@ -5310,12 +5333,12 @@
           <a:p>
             <a:pPr>
               <a:lnSpc>
-                <a:spcPct val="130000"/>
+                <a:spcPct val="110000"/>
               </a:lnSpc>
               <a:spcAft>
-                <a:spcPts val="1000"/>
+                <a:spcPts val="400"/>
               </a:spcAft>
-              <a:defRPr sz="1800">
+              <a:defRPr sz="1700">
                 <a:solidFill>
                   <a:srgbClr val="333333"/>
                 </a:solidFill>
@@ -5329,12 +5352,12 @@
           <a:p>
             <a:pPr>
               <a:lnSpc>
-                <a:spcPct val="130000"/>
+                <a:spcPct val="110000"/>
               </a:lnSpc>
               <a:spcAft>
-                <a:spcPts val="1000"/>
+                <a:spcPts val="400"/>
               </a:spcAft>
-              <a:defRPr sz="1800">
+              <a:defRPr sz="1700">
                 <a:solidFill>
                   <a:srgbClr val="333333"/>
                 </a:solidFill>
@@ -5348,12 +5371,12 @@
           <a:p>
             <a:pPr>
               <a:lnSpc>
-                <a:spcPct val="130000"/>
+                <a:spcPct val="110000"/>
               </a:lnSpc>
               <a:spcAft>
-                <a:spcPts val="1000"/>
+                <a:spcPts val="400"/>
               </a:spcAft>
-              <a:defRPr sz="1800">
+              <a:defRPr sz="1700">
                 <a:solidFill>
                   <a:srgbClr val="333333"/>
                 </a:solidFill>
@@ -5374,7 +5397,7 @@
         </p:nvSpPr>
         <p:spPr>
           <a:xfrm>
-            <a:off x="512064" y="6400800"/>
+            <a:off x="512064" y="6528816"/>
             <a:ext cx="11167567" cy="12700"/>
           </a:xfrm>
           <a:prstGeom prst="rect">
@@ -5417,7 +5440,7 @@
         </p:nvSpPr>
         <p:spPr>
           <a:xfrm>
-            <a:off x="10948111" y="6492240"/>
+            <a:off x="10948111" y="6620256"/>
             <a:ext cx="731520" cy="274320"/>
           </a:xfrm>
           <a:prstGeom prst="rect">
@@ -5472,7 +5495,7 @@
         <p:spPr>
           <a:xfrm>
             <a:off x="0" y="0"/>
-            <a:ext cx="12191695" cy="886968"/>
+            <a:ext cx="12191695" cy="658368"/>
           </a:xfrm>
           <a:prstGeom prst="rect">
             <a:avLst/>
@@ -5515,7 +5538,7 @@
         <p:spPr>
           <a:xfrm>
             <a:off x="0" y="0"/>
-            <a:ext cx="54864" cy="886968"/>
+            <a:ext cx="54864" cy="658368"/>
           </a:xfrm>
           <a:prstGeom prst="rect">
             <a:avLst/>
@@ -5557,7 +5580,7 @@
         </p:nvSpPr>
         <p:spPr>
           <a:xfrm>
-            <a:off x="10308031" y="283464"/>
+            <a:off x="10308031" y="169164"/>
             <a:ext cx="1371600" cy="320040"/>
           </a:xfrm>
           <a:prstGeom prst="roundRect">
@@ -5616,7 +5639,7 @@
         </p:nvSpPr>
         <p:spPr>
           <a:xfrm>
-            <a:off x="603504" y="260604"/>
+            <a:off x="603504" y="146304"/>
             <a:ext cx="9613087" cy="457200"/>
           </a:xfrm>
           <a:prstGeom prst="rect">
@@ -5631,7 +5654,7 @@
           <a:lstStyle/>
           <a:p>
             <a:pPr>
-              <a:defRPr sz="2400" b="1">
+              <a:defRPr sz="2000" b="1">
                 <a:solidFill>
                   <a:srgbClr val="FFFFFF"/>
                 </a:solidFill>
@@ -5652,8 +5675,8 @@
         </p:nvSpPr>
         <p:spPr>
           <a:xfrm>
-            <a:off x="512064" y="1325880"/>
-            <a:ext cx="5400903" cy="411480"/>
+            <a:off x="512064" y="941832"/>
+            <a:ext cx="5400903" cy="347472"/>
           </a:xfrm>
           <a:prstGeom prst="roundRect">
             <a:avLst/>
@@ -5687,9 +5710,9 @@
           <a:p>
             <a:pPr algn="ctr">
               <a:spcAft>
-                <a:spcPts val="800"/>
+                <a:spcPts val="400"/>
               </a:spcAft>
-              <a:defRPr sz="2000" b="1">
+              <a:defRPr sz="1600" b="1">
                 <a:solidFill>
                   <a:srgbClr val="003366"/>
                 </a:solidFill>
@@ -5710,8 +5733,8 @@
         </p:nvSpPr>
         <p:spPr>
           <a:xfrm>
-            <a:off x="512064" y="1874520"/>
-            <a:ext cx="5400903" cy="4471416"/>
+            <a:off x="512064" y="1371600"/>
+            <a:ext cx="5400903" cy="5065776"/>
           </a:xfrm>
           <a:prstGeom prst="rect">
             <a:avLst/>
@@ -5726,12 +5749,12 @@
           <a:p>
             <a:pPr>
               <a:lnSpc>
-                <a:spcPct val="130000"/>
+                <a:spcPct val="110000"/>
               </a:lnSpc>
               <a:spcAft>
-                <a:spcPts val="1000"/>
+                <a:spcPts val="400"/>
               </a:spcAft>
-              <a:defRPr sz="1600">
+              <a:defRPr sz="1400">
                 <a:solidFill>
                   <a:srgbClr val="333333"/>
                 </a:solidFill>
@@ -5745,12 +5768,12 @@
           <a:p>
             <a:pPr>
               <a:lnSpc>
-                <a:spcPct val="130000"/>
+                <a:spcPct val="110000"/>
               </a:lnSpc>
               <a:spcAft>
-                <a:spcPts val="1000"/>
+                <a:spcPts val="400"/>
               </a:spcAft>
-              <a:defRPr sz="1600">
+              <a:defRPr sz="1400">
                 <a:solidFill>
                   <a:srgbClr val="333333"/>
                 </a:solidFill>
@@ -5764,12 +5787,12 @@
           <a:p>
             <a:pPr>
               <a:lnSpc>
-                <a:spcPct val="130000"/>
+                <a:spcPct val="110000"/>
               </a:lnSpc>
               <a:spcAft>
-                <a:spcPts val="1000"/>
+                <a:spcPts val="400"/>
               </a:spcAft>
-              <a:defRPr sz="1600">
+              <a:defRPr sz="1400">
                 <a:solidFill>
                   <a:srgbClr val="333333"/>
                 </a:solidFill>
@@ -5783,12 +5806,12 @@
           <a:p>
             <a:pPr>
               <a:lnSpc>
-                <a:spcPct val="130000"/>
+                <a:spcPct val="110000"/>
               </a:lnSpc>
               <a:spcAft>
-                <a:spcPts val="1000"/>
+                <a:spcPts val="400"/>
               </a:spcAft>
-              <a:defRPr sz="1600">
+              <a:defRPr sz="1400">
                 <a:solidFill>
                   <a:srgbClr val="333333"/>
                 </a:solidFill>
@@ -5809,8 +5832,8 @@
         </p:nvSpPr>
         <p:spPr>
           <a:xfrm>
-            <a:off x="6278727" y="1325880"/>
-            <a:ext cx="5400903" cy="411480"/>
+            <a:off x="6278727" y="941832"/>
+            <a:ext cx="5400903" cy="347472"/>
           </a:xfrm>
           <a:prstGeom prst="roundRect">
             <a:avLst/>
@@ -5844,9 +5867,9 @@
           <a:p>
             <a:pPr algn="ctr">
               <a:spcAft>
-                <a:spcPts val="800"/>
+                <a:spcPts val="400"/>
               </a:spcAft>
-              <a:defRPr sz="2000" b="1">
+              <a:defRPr sz="1600" b="1">
                 <a:solidFill>
                   <a:srgbClr val="003366"/>
                 </a:solidFill>
@@ -5867,8 +5890,8 @@
         </p:nvSpPr>
         <p:spPr>
           <a:xfrm>
-            <a:off x="6278727" y="1874520"/>
-            <a:ext cx="5400903" cy="4471416"/>
+            <a:off x="6278727" y="1371600"/>
+            <a:ext cx="5400903" cy="5065776"/>
           </a:xfrm>
           <a:prstGeom prst="rect">
             <a:avLst/>
@@ -5883,12 +5906,12 @@
           <a:p>
             <a:pPr>
               <a:lnSpc>
-                <a:spcPct val="130000"/>
+                <a:spcPct val="110000"/>
               </a:lnSpc>
               <a:spcAft>
-                <a:spcPts val="1000"/>
+                <a:spcPts val="400"/>
               </a:spcAft>
-              <a:defRPr sz="1600">
+              <a:defRPr sz="1400">
                 <a:solidFill>
                   <a:srgbClr val="333333"/>
                 </a:solidFill>
@@ -5902,12 +5925,12 @@
           <a:p>
             <a:pPr>
               <a:lnSpc>
-                <a:spcPct val="130000"/>
+                <a:spcPct val="110000"/>
               </a:lnSpc>
               <a:spcAft>
-                <a:spcPts val="1000"/>
+                <a:spcPts val="400"/>
               </a:spcAft>
-              <a:defRPr sz="1600">
+              <a:defRPr sz="1400">
                 <a:solidFill>
                   <a:srgbClr val="333333"/>
                 </a:solidFill>
@@ -5921,12 +5944,12 @@
           <a:p>
             <a:pPr>
               <a:lnSpc>
-                <a:spcPct val="130000"/>
+                <a:spcPct val="110000"/>
               </a:lnSpc>
               <a:spcAft>
-                <a:spcPts val="1000"/>
+                <a:spcPts val="400"/>
               </a:spcAft>
-              <a:defRPr sz="1600">
+              <a:defRPr sz="1400">
                 <a:solidFill>
                   <a:srgbClr val="333333"/>
                 </a:solidFill>
@@ -5940,12 +5963,12 @@
           <a:p>
             <a:pPr>
               <a:lnSpc>
-                <a:spcPct val="130000"/>
+                <a:spcPct val="110000"/>
               </a:lnSpc>
               <a:spcAft>
-                <a:spcPts val="1000"/>
+                <a:spcPts val="400"/>
               </a:spcAft>
-              <a:defRPr sz="1600">
+              <a:defRPr sz="1400">
                 <a:solidFill>
                   <a:srgbClr val="333333"/>
                 </a:solidFill>
@@ -5966,7 +5989,7 @@
         </p:nvSpPr>
         <p:spPr>
           <a:xfrm>
-            <a:off x="512064" y="6400800"/>
+            <a:off x="512064" y="6528816"/>
             <a:ext cx="11167567" cy="12700"/>
           </a:xfrm>
           <a:prstGeom prst="rect">
@@ -6009,7 +6032,7 @@
         </p:nvSpPr>
         <p:spPr>
           <a:xfrm>
-            <a:off x="10948111" y="6492240"/>
+            <a:off x="10948111" y="6620256"/>
             <a:ext cx="731520" cy="274320"/>
           </a:xfrm>
           <a:prstGeom prst="rect">
@@ -6064,7 +6087,7 @@
         <p:spPr>
           <a:xfrm>
             <a:off x="0" y="0"/>
-            <a:ext cx="12191695" cy="886968"/>
+            <a:ext cx="12191695" cy="658368"/>
           </a:xfrm>
           <a:prstGeom prst="rect">
             <a:avLst/>
@@ -6107,7 +6130,7 @@
         <p:spPr>
           <a:xfrm>
             <a:off x="0" y="0"/>
-            <a:ext cx="54864" cy="886968"/>
+            <a:ext cx="54864" cy="658368"/>
           </a:xfrm>
           <a:prstGeom prst="rect">
             <a:avLst/>
@@ -6149,7 +6172,7 @@
         </p:nvSpPr>
         <p:spPr>
           <a:xfrm>
-            <a:off x="10308031" y="283464"/>
+            <a:off x="10308031" y="169164"/>
             <a:ext cx="1371600" cy="320040"/>
           </a:xfrm>
           <a:prstGeom prst="roundRect">
@@ -6208,7 +6231,7 @@
         </p:nvSpPr>
         <p:spPr>
           <a:xfrm>
-            <a:off x="603504" y="260604"/>
+            <a:off x="603504" y="146304"/>
             <a:ext cx="9613087" cy="457200"/>
           </a:xfrm>
           <a:prstGeom prst="rect">
@@ -6223,7 +6246,7 @@
           <a:lstStyle/>
           <a:p>
             <a:pPr>
-              <a:defRPr sz="2400" b="1">
+              <a:defRPr sz="2000" b="1">
                 <a:solidFill>
                   <a:srgbClr val="FFFFFF"/>
                 </a:solidFill>
@@ -6244,8 +6267,8 @@
         </p:nvSpPr>
         <p:spPr>
           <a:xfrm>
-            <a:off x="512064" y="1325880"/>
-            <a:ext cx="11167567" cy="4837176"/>
+            <a:off x="512064" y="941832"/>
+            <a:ext cx="11167567" cy="5431536"/>
           </a:xfrm>
           <a:prstGeom prst="rect">
             <a:avLst/>
@@ -6260,12 +6283,12 @@
           <a:p>
             <a:pPr>
               <a:lnSpc>
-                <a:spcPct val="130000"/>
+                <a:spcPct val="110000"/>
               </a:lnSpc>
               <a:spcAft>
-                <a:spcPts val="1000"/>
+                <a:spcPts val="400"/>
               </a:spcAft>
-              <a:defRPr sz="2000">
+              <a:defRPr sz="1700">
                 <a:solidFill>
                   <a:srgbClr val="333333"/>
                 </a:solidFill>
@@ -6279,12 +6302,12 @@
           <a:p>
             <a:pPr>
               <a:lnSpc>
-                <a:spcPct val="130000"/>
+                <a:spcPct val="110000"/>
               </a:lnSpc>
               <a:spcAft>
-                <a:spcPts val="1000"/>
+                <a:spcPts val="400"/>
               </a:spcAft>
-              <a:defRPr sz="2000">
+              <a:defRPr sz="1700">
                 <a:solidFill>
                   <a:srgbClr val="333333"/>
                 </a:solidFill>
@@ -6298,12 +6321,12 @@
           <a:p>
             <a:pPr>
               <a:lnSpc>
-                <a:spcPct val="130000"/>
+                <a:spcPct val="110000"/>
               </a:lnSpc>
               <a:spcAft>
-                <a:spcPts val="1000"/>
+                <a:spcPts val="400"/>
               </a:spcAft>
-              <a:defRPr sz="2000">
+              <a:defRPr sz="1700">
                 <a:solidFill>
                   <a:srgbClr val="333333"/>
                 </a:solidFill>
@@ -6317,12 +6340,12 @@
           <a:p>
             <a:pPr>
               <a:lnSpc>
-                <a:spcPct val="130000"/>
+                <a:spcPct val="110000"/>
               </a:lnSpc>
               <a:spcAft>
-                <a:spcPts val="1000"/>
+                <a:spcPts val="400"/>
               </a:spcAft>
-              <a:defRPr sz="2000">
+              <a:defRPr sz="1700">
                 <a:solidFill>
                   <a:srgbClr val="333333"/>
                 </a:solidFill>
@@ -6336,12 +6359,12 @@
           <a:p>
             <a:pPr>
               <a:lnSpc>
-                <a:spcPct val="130000"/>
+                <a:spcPct val="110000"/>
               </a:lnSpc>
               <a:spcAft>
-                <a:spcPts val="1000"/>
+                <a:spcPts val="400"/>
               </a:spcAft>
-              <a:defRPr sz="2000">
+              <a:defRPr sz="1700">
                 <a:solidFill>
                   <a:srgbClr val="333333"/>
                 </a:solidFill>
@@ -6362,7 +6385,7 @@
         </p:nvSpPr>
         <p:spPr>
           <a:xfrm>
-            <a:off x="512064" y="6400800"/>
+            <a:off x="512064" y="6528816"/>
             <a:ext cx="11167567" cy="12700"/>
           </a:xfrm>
           <a:prstGeom prst="rect">
@@ -6405,7 +6428,7 @@
         </p:nvSpPr>
         <p:spPr>
           <a:xfrm>
-            <a:off x="10948111" y="6492240"/>
+            <a:off x="10948111" y="6620256"/>
             <a:ext cx="731520" cy="274320"/>
           </a:xfrm>
           <a:prstGeom prst="rect">
@@ -6460,7 +6483,7 @@
         <p:spPr>
           <a:xfrm>
             <a:off x="0" y="0"/>
-            <a:ext cx="12191695" cy="886968"/>
+            <a:ext cx="12191695" cy="658368"/>
           </a:xfrm>
           <a:prstGeom prst="rect">
             <a:avLst/>
@@ -6503,7 +6526,7 @@
         <p:spPr>
           <a:xfrm>
             <a:off x="0" y="0"/>
-            <a:ext cx="54864" cy="886968"/>
+            <a:ext cx="54864" cy="658368"/>
           </a:xfrm>
           <a:prstGeom prst="rect">
             <a:avLst/>
@@ -6545,7 +6568,7 @@
         </p:nvSpPr>
         <p:spPr>
           <a:xfrm>
-            <a:off x="10308031" y="283464"/>
+            <a:off x="10308031" y="169164"/>
             <a:ext cx="1371600" cy="320040"/>
           </a:xfrm>
           <a:prstGeom prst="roundRect">
@@ -6604,7 +6627,7 @@
         </p:nvSpPr>
         <p:spPr>
           <a:xfrm>
-            <a:off x="603504" y="260604"/>
+            <a:off x="603504" y="146304"/>
             <a:ext cx="9613087" cy="457200"/>
           </a:xfrm>
           <a:prstGeom prst="rect">
@@ -6619,7 +6642,7 @@
           <a:lstStyle/>
           <a:p>
             <a:pPr>
-              <a:defRPr sz="2400" b="1">
+              <a:defRPr sz="2000" b="1">
                 <a:solidFill>
                   <a:srgbClr val="FFFFFF"/>
                 </a:solidFill>
@@ -6640,8 +6663,8 @@
         </p:nvSpPr>
         <p:spPr>
           <a:xfrm>
-            <a:off x="512064" y="1325880"/>
-            <a:ext cx="11167567" cy="4837176"/>
+            <a:off x="512064" y="941832"/>
+            <a:ext cx="11167567" cy="5431536"/>
           </a:xfrm>
           <a:prstGeom prst="rect">
             <a:avLst/>
@@ -6656,12 +6679,12 @@
           <a:p>
             <a:pPr>
               <a:lnSpc>
-                <a:spcPct val="130000"/>
+                <a:spcPct val="110000"/>
               </a:lnSpc>
               <a:spcAft>
-                <a:spcPts val="1000"/>
+                <a:spcPts val="400"/>
               </a:spcAft>
-              <a:defRPr sz="2000">
+              <a:defRPr sz="1700">
                 <a:solidFill>
                   <a:srgbClr val="333333"/>
                 </a:solidFill>
@@ -6675,12 +6698,12 @@
           <a:p>
             <a:pPr>
               <a:lnSpc>
-                <a:spcPct val="130000"/>
+                <a:spcPct val="110000"/>
               </a:lnSpc>
               <a:spcAft>
-                <a:spcPts val="1000"/>
+                <a:spcPts val="400"/>
               </a:spcAft>
-              <a:defRPr sz="2000">
+              <a:defRPr sz="1700">
                 <a:solidFill>
                   <a:srgbClr val="333333"/>
                 </a:solidFill>
@@ -6694,12 +6717,12 @@
           <a:p>
             <a:pPr>
               <a:lnSpc>
-                <a:spcPct val="130000"/>
+                <a:spcPct val="110000"/>
               </a:lnSpc>
               <a:spcAft>
-                <a:spcPts val="1000"/>
+                <a:spcPts val="400"/>
               </a:spcAft>
-              <a:defRPr sz="2000">
+              <a:defRPr sz="1700">
                 <a:solidFill>
                   <a:srgbClr val="333333"/>
                 </a:solidFill>
@@ -6713,12 +6736,12 @@
           <a:p>
             <a:pPr>
               <a:lnSpc>
-                <a:spcPct val="130000"/>
+                <a:spcPct val="110000"/>
               </a:lnSpc>
               <a:spcAft>
-                <a:spcPts val="1000"/>
+                <a:spcPts val="400"/>
               </a:spcAft>
-              <a:defRPr sz="2000">
+              <a:defRPr sz="1700">
                 <a:solidFill>
                   <a:srgbClr val="333333"/>
                 </a:solidFill>
@@ -6732,12 +6755,12 @@
           <a:p>
             <a:pPr>
               <a:lnSpc>
-                <a:spcPct val="130000"/>
+                <a:spcPct val="110000"/>
               </a:lnSpc>
               <a:spcAft>
-                <a:spcPts val="1000"/>
+                <a:spcPts val="400"/>
               </a:spcAft>
-              <a:defRPr sz="2000">
+              <a:defRPr sz="1700">
                 <a:solidFill>
                   <a:srgbClr val="333333"/>
                 </a:solidFill>
@@ -6758,7 +6781,7 @@
         </p:nvSpPr>
         <p:spPr>
           <a:xfrm>
-            <a:off x="512064" y="6400800"/>
+            <a:off x="512064" y="6528816"/>
             <a:ext cx="11167567" cy="12700"/>
           </a:xfrm>
           <a:prstGeom prst="rect">
@@ -6801,7 +6824,7 @@
         </p:nvSpPr>
         <p:spPr>
           <a:xfrm>
-            <a:off x="10948111" y="6492240"/>
+            <a:off x="10948111" y="6620256"/>
             <a:ext cx="731520" cy="274320"/>
           </a:xfrm>
           <a:prstGeom prst="rect">
@@ -6856,7 +6879,7 @@
         <p:spPr>
           <a:xfrm>
             <a:off x="0" y="0"/>
-            <a:ext cx="12191695" cy="886968"/>
+            <a:ext cx="12191695" cy="658368"/>
           </a:xfrm>
           <a:prstGeom prst="rect">
             <a:avLst/>
@@ -6899,7 +6922,7 @@
         <p:spPr>
           <a:xfrm>
             <a:off x="0" y="0"/>
-            <a:ext cx="54864" cy="886968"/>
+            <a:ext cx="54864" cy="658368"/>
           </a:xfrm>
           <a:prstGeom prst="rect">
             <a:avLst/>
@@ -6941,7 +6964,7 @@
         </p:nvSpPr>
         <p:spPr>
           <a:xfrm>
-            <a:off x="10308031" y="283464"/>
+            <a:off x="10308031" y="169164"/>
             <a:ext cx="1371600" cy="320040"/>
           </a:xfrm>
           <a:prstGeom prst="roundRect">
@@ -7000,7 +7023,7 @@
         </p:nvSpPr>
         <p:spPr>
           <a:xfrm>
-            <a:off x="603504" y="260604"/>
+            <a:off x="603504" y="146304"/>
             <a:ext cx="9613087" cy="457200"/>
           </a:xfrm>
           <a:prstGeom prst="rect">
@@ -7015,7 +7038,7 @@
           <a:lstStyle/>
           <a:p>
             <a:pPr>
-              <a:defRPr sz="2400" b="1">
+              <a:defRPr sz="2000" b="1">
                 <a:solidFill>
                   <a:srgbClr val="FFFFFF"/>
                 </a:solidFill>
@@ -7036,8 +7059,8 @@
         </p:nvSpPr>
         <p:spPr>
           <a:xfrm>
-            <a:off x="512064" y="1325880"/>
-            <a:ext cx="11167567" cy="4837176"/>
+            <a:off x="512064" y="941832"/>
+            <a:ext cx="11167567" cy="5431536"/>
           </a:xfrm>
           <a:prstGeom prst="rect">
             <a:avLst/>
@@ -7052,12 +7075,12 @@
           <a:p>
             <a:pPr>
               <a:lnSpc>
-                <a:spcPct val="130000"/>
+                <a:spcPct val="110000"/>
               </a:lnSpc>
               <a:spcAft>
-                <a:spcPts val="1000"/>
+                <a:spcPts val="400"/>
               </a:spcAft>
-              <a:defRPr sz="2000">
+              <a:defRPr sz="1700">
                 <a:solidFill>
                   <a:srgbClr val="333333"/>
                 </a:solidFill>
@@ -7071,12 +7094,12 @@
           <a:p>
             <a:pPr>
               <a:lnSpc>
-                <a:spcPct val="130000"/>
+                <a:spcPct val="110000"/>
               </a:lnSpc>
               <a:spcAft>
-                <a:spcPts val="1000"/>
+                <a:spcPts val="400"/>
               </a:spcAft>
-              <a:defRPr sz="2000">
+              <a:defRPr sz="1700">
                 <a:solidFill>
                   <a:srgbClr val="333333"/>
                 </a:solidFill>
@@ -7090,12 +7113,12 @@
           <a:p>
             <a:pPr>
               <a:lnSpc>
-                <a:spcPct val="130000"/>
+                <a:spcPct val="110000"/>
               </a:lnSpc>
               <a:spcAft>
-                <a:spcPts val="1000"/>
+                <a:spcPts val="400"/>
               </a:spcAft>
-              <a:defRPr sz="2000">
+              <a:defRPr sz="1700">
                 <a:solidFill>
                   <a:srgbClr val="333333"/>
                 </a:solidFill>
@@ -7109,12 +7132,12 @@
           <a:p>
             <a:pPr>
               <a:lnSpc>
-                <a:spcPct val="130000"/>
+                <a:spcPct val="110000"/>
               </a:lnSpc>
               <a:spcAft>
-                <a:spcPts val="1000"/>
+                <a:spcPts val="400"/>
               </a:spcAft>
-              <a:defRPr sz="2000">
+              <a:defRPr sz="1700">
                 <a:solidFill>
                   <a:srgbClr val="333333"/>
                 </a:solidFill>
@@ -7128,12 +7151,12 @@
           <a:p>
             <a:pPr>
               <a:lnSpc>
-                <a:spcPct val="130000"/>
+                <a:spcPct val="110000"/>
               </a:lnSpc>
               <a:spcAft>
-                <a:spcPts val="1000"/>
+                <a:spcPts val="400"/>
               </a:spcAft>
-              <a:defRPr sz="2000">
+              <a:defRPr sz="1700">
                 <a:solidFill>
                   <a:srgbClr val="333333"/>
                 </a:solidFill>
@@ -7154,7 +7177,7 @@
         </p:nvSpPr>
         <p:spPr>
           <a:xfrm>
-            <a:off x="512064" y="6400800"/>
+            <a:off x="512064" y="6528816"/>
             <a:ext cx="11167567" cy="12700"/>
           </a:xfrm>
           <a:prstGeom prst="rect">
@@ -7197,7 +7220,7 @@
         </p:nvSpPr>
         <p:spPr>
           <a:xfrm>
-            <a:off x="10948111" y="6492240"/>
+            <a:off x="10948111" y="6620256"/>
             <a:ext cx="731520" cy="274320"/>
           </a:xfrm>
           <a:prstGeom prst="rect">
@@ -7252,7 +7275,7 @@
         <p:spPr>
           <a:xfrm>
             <a:off x="0" y="0"/>
-            <a:ext cx="12191695" cy="886968"/>
+            <a:ext cx="12191695" cy="658368"/>
           </a:xfrm>
           <a:prstGeom prst="rect">
             <a:avLst/>
@@ -7295,7 +7318,7 @@
         <p:spPr>
           <a:xfrm>
             <a:off x="0" y="0"/>
-            <a:ext cx="54864" cy="886968"/>
+            <a:ext cx="54864" cy="658368"/>
           </a:xfrm>
           <a:prstGeom prst="rect">
             <a:avLst/>
@@ -7337,7 +7360,7 @@
         </p:nvSpPr>
         <p:spPr>
           <a:xfrm>
-            <a:off x="10308031" y="283464"/>
+            <a:off x="10308031" y="169164"/>
             <a:ext cx="1371600" cy="320040"/>
           </a:xfrm>
           <a:prstGeom prst="roundRect">
@@ -7396,7 +7419,7 @@
         </p:nvSpPr>
         <p:spPr>
           <a:xfrm>
-            <a:off x="603504" y="260604"/>
+            <a:off x="603504" y="146304"/>
             <a:ext cx="9613087" cy="457200"/>
           </a:xfrm>
           <a:prstGeom prst="rect">
@@ -7411,7 +7434,7 @@
           <a:lstStyle/>
           <a:p>
             <a:pPr>
-              <a:defRPr sz="2400" b="1">
+              <a:defRPr sz="2000" b="1">
                 <a:solidFill>
                   <a:srgbClr val="FFFFFF"/>
                 </a:solidFill>
@@ -7432,8 +7455,8 @@
         </p:nvSpPr>
         <p:spPr>
           <a:xfrm>
-            <a:off x="512064" y="1325880"/>
-            <a:ext cx="11167567" cy="4837176"/>
+            <a:off x="512064" y="941832"/>
+            <a:ext cx="11167567" cy="5431536"/>
           </a:xfrm>
           <a:prstGeom prst="rect">
             <a:avLst/>
@@ -7448,12 +7471,12 @@
           <a:p>
             <a:pPr>
               <a:lnSpc>
-                <a:spcPct val="130000"/>
+                <a:spcPct val="110000"/>
               </a:lnSpc>
               <a:spcAft>
-                <a:spcPts val="1000"/>
+                <a:spcPts val="400"/>
               </a:spcAft>
-              <a:defRPr sz="2000">
+              <a:defRPr sz="1700">
                 <a:solidFill>
                   <a:srgbClr val="333333"/>
                 </a:solidFill>
@@ -7467,12 +7490,12 @@
           <a:p>
             <a:pPr>
               <a:lnSpc>
-                <a:spcPct val="130000"/>
+                <a:spcPct val="110000"/>
               </a:lnSpc>
               <a:spcAft>
-                <a:spcPts val="1000"/>
+                <a:spcPts val="400"/>
               </a:spcAft>
-              <a:defRPr sz="2000">
+              <a:defRPr sz="1700">
                 <a:solidFill>
                   <a:srgbClr val="333333"/>
                 </a:solidFill>
@@ -7486,12 +7509,12 @@
           <a:p>
             <a:pPr>
               <a:lnSpc>
-                <a:spcPct val="130000"/>
+                <a:spcPct val="110000"/>
               </a:lnSpc>
               <a:spcAft>
-                <a:spcPts val="1000"/>
+                <a:spcPts val="400"/>
               </a:spcAft>
-              <a:defRPr sz="2000">
+              <a:defRPr sz="1700">
                 <a:solidFill>
                   <a:srgbClr val="333333"/>
                 </a:solidFill>
@@ -7505,12 +7528,12 @@
           <a:p>
             <a:pPr>
               <a:lnSpc>
-                <a:spcPct val="130000"/>
+                <a:spcPct val="110000"/>
               </a:lnSpc>
               <a:spcAft>
-                <a:spcPts val="1000"/>
+                <a:spcPts val="400"/>
               </a:spcAft>
-              <a:defRPr sz="2000">
+              <a:defRPr sz="1700">
                 <a:solidFill>
                   <a:srgbClr val="333333"/>
                 </a:solidFill>
@@ -7524,12 +7547,12 @@
           <a:p>
             <a:pPr>
               <a:lnSpc>
-                <a:spcPct val="130000"/>
+                <a:spcPct val="110000"/>
               </a:lnSpc>
               <a:spcAft>
-                <a:spcPts val="1000"/>
+                <a:spcPts val="400"/>
               </a:spcAft>
-              <a:defRPr sz="2000">
+              <a:defRPr sz="1700">
                 <a:solidFill>
                   <a:srgbClr val="333333"/>
                 </a:solidFill>
@@ -7550,7 +7573,7 @@
         </p:nvSpPr>
         <p:spPr>
           <a:xfrm>
-            <a:off x="512064" y="6400800"/>
+            <a:off x="512064" y="6528816"/>
             <a:ext cx="11167567" cy="12700"/>
           </a:xfrm>
           <a:prstGeom prst="rect">
@@ -7593,7 +7616,7 @@
         </p:nvSpPr>
         <p:spPr>
           <a:xfrm>
-            <a:off x="10948111" y="6492240"/>
+            <a:off x="10948111" y="6620256"/>
             <a:ext cx="731520" cy="274320"/>
           </a:xfrm>
           <a:prstGeom prst="rect">

</xml_diff>